<commit_message>
Show essential 현업 roles as text in slide 3
Co-Authored-By: Claude Opus 5.5 <noreply@anthropic.com>
Claude-Session: https://claude.ai/code/session_014TbtPTXZRwab3hp8YY9eJi
</commit_message>
<xml_diff>
--- a/03_추진역할및조직_현업반영.pptx
+++ b/03_추진역할및조직_현업반영.pptx
@@ -502,21 +502,14 @@
           <a:p>
             <a:r>
               <a:rPr lang="en-US" dirty="0"/>
-              <a:t>[현업 세부 역할]
-P1 의견 청취: 인터뷰 참여, Pain Point 제공
-P1 문제 정의·KPI 가설: 업무량·비용 데이터 제공, 가설 검토
-P1 과제 후보 선정: 과제 후보 제안, 업무 니즈 우선순위 확인
-P2 As-Is 분석: 실제 업무 흐름·예외 사례 설명
-P2 To-Be 설계: 사람이 맡을 역할 정의, 현장 수용성 검토
-P2 레거시 검토: 시스템 사용 현황 공유
-P3 기술 타당성 검증: 업무 데이터·샘플 제공
-P3 우선순위화·과제 확정: 과제 Owner 지정, 추진 의사결정
-P3 ROI·KPI Baseline: 현재 실적 데이터 제공, Baseline 합의
-P4 아키텍처 설계·개발: 중간 결과 피드백, 업무 질의 대응
-P4 사용자 테스트: 테스트 직접 수행, 개선 요구사항 제기
-P5 성공기준·KPI 확정: KPI 목표 합의·승인
-P5 운영 모델 설계: 현업 운영 담당자 R&amp;R 정의, 프로세스 반영
-P5 운영 이관 협의: 운영 인수, 현장 활용 정착</a:t>
+              <a:t>[현업 역할] 꼭 필요한 활동에만 표기
+P1 의견 청취 - Pain Point 제공: 현업 인터뷰를 통해 실제 문제를 제기
+P2 As-Is 분석 - 업무 흐름 설명: 실제 업무 흐름과 예외 사례를 설명
+P3 기술 타당성 검증 - 업무 데이터 제공: 검증용 데이터·샘플 제공
+P3 과제 확정 - 과제 Owner 지정: 과제별 현업 책임자 지정
+P4 사용자 테스트 - 사용자 테스트 수행: 직접 테스트하고 개선 요구사항 제기
+P5 KPI 확정 - KPI 목표 합의: 성과 목표를 현업과 합의
+P5 운영 이관 - 운영 인수·정착: 운영 인수 및 현장 활용 정착</a:t>
             </a:r>
             <a:endParaRPr lang="en-US" dirty="0"/>
           </a:p>
@@ -991,11 +984,11 @@
               <a:tblPr/>
               <a:tblGrid>
                 <a:gridCol w="1417320"/>
-                <a:gridCol w="4645152"/>
-                <a:gridCol w="1325880"/>
-                <a:gridCol w="1325880"/>
-                <a:gridCol w="1325880"/>
-                <a:gridCol w="1325880"/>
+                <a:gridCol w="4507992"/>
+                <a:gridCol w="1234440"/>
+                <a:gridCol w="1234440"/>
+                <a:gridCol w="1234440"/>
+                <a:gridCol w="1737360"/>
               </a:tblGrid>
               <a:tr h="457200">
                 <a:tc>
@@ -1767,17 +1760,17 @@
                         <a:buNone/>
                       </a:pPr>
                       <a:r>
-                        <a:rPr lang="en-US" sz="1200" i="1" dirty="0">
-                          <a:solidFill>
-                            <a:srgbClr val="FFFFFF"/>
-                          </a:solidFill>
-                          <a:latin typeface="맑은 고딕" pitchFamily="34" charset="0"/>
-                          <a:ea typeface="맑은 고딕" pitchFamily="34" charset="-122"/>
-                          <a:cs typeface="맑은 고딕" pitchFamily="34" charset="-120"/>
-                        </a:rPr>
-                        <a:t>협업</a:t>
-                      </a:r>
-                      <a:endParaRPr lang="en-US" sz="1200" dirty="0">
+                        <a:rPr lang="en-US" sz="1150" b="1" dirty="0">
+                          <a:solidFill>
+                            <a:srgbClr val="1F3F6E"/>
+                          </a:solidFill>
+                          <a:latin typeface="맑은 고딕" pitchFamily="34" charset="0"/>
+                          <a:ea typeface="맑은 고딕" pitchFamily="34" charset="-122"/>
+                          <a:cs typeface="맑은 고딕" pitchFamily="34" charset="-120"/>
+                        </a:rPr>
+                        <a:t>Pain Point 제공</a:t>
+                      </a:r>
+                      <a:endParaRPr lang="en-US" sz="1150" dirty="0">
                         <a:latin typeface="맑은 고딕" charset="0"/>
                         <a:ea typeface="맑은 고딕" charset="0"/>
                         <a:cs typeface="맑은 고딕" charset="0"/>
@@ -1787,42 +1780,42 @@
                   <a:tcPr marL="91440" marR="91440" marT="45720" marB="45720" anchor="ctr">
                     <a:lnL w="9525" cap="flat" cmpd="sng" algn="ctr">
                       <a:solidFill>
-                        <a:srgbClr val="FFFFFF"/>
-                      </a:solidFill>
-                      <a:prstDash val="solid"/>
-                      <a:round/>
-                      <a:headEnd type="none" w="med" len="med"/>
-                      <a:tailEnd type="none" w="med" len="med"/>
-                    </a:lnL>
-                    <a:lnR w="9525" cap="flat" cmpd="sng" algn="ctr">
-                      <a:solidFill>
-                        <a:srgbClr val="FFFFFF"/>
-                      </a:solidFill>
-                      <a:prstDash val="solid"/>
-                      <a:round/>
-                      <a:headEnd type="none" w="med" len="med"/>
-                      <a:tailEnd type="none" w="med" len="med"/>
-                    </a:lnR>
-                    <a:lnT w="9525" cap="flat" cmpd="sng" algn="ctr">
-                      <a:solidFill>
-                        <a:srgbClr val="FFFFFF"/>
-                      </a:solidFill>
-                      <a:prstDash val="solid"/>
-                      <a:round/>
-                      <a:headEnd type="none" w="med" len="med"/>
-                      <a:tailEnd type="none" w="med" len="med"/>
-                    </a:lnT>
-                    <a:lnB w="9525" cap="flat" cmpd="sng" algn="ctr">
-                      <a:solidFill>
-                        <a:srgbClr val="FFFFFF"/>
-                      </a:solidFill>
-                      <a:prstDash val="solid"/>
-                      <a:round/>
-                      <a:headEnd type="none" w="med" len="med"/>
-                      <a:tailEnd type="none" w="med" len="med"/>
-                    </a:lnB>
-                    <a:solidFill>
-                      <a:srgbClr val="5B8ED6"/>
+                        <a:srgbClr val="BFBFBF"/>
+                      </a:solidFill>
+                      <a:prstDash val="solid"/>
+                      <a:round/>
+                      <a:headEnd type="none" w="med" len="med"/>
+                      <a:tailEnd type="none" w="med" len="med"/>
+                    </a:lnL>
+                    <a:lnR w="9525" cap="flat" cmpd="sng" algn="ctr">
+                      <a:solidFill>
+                        <a:srgbClr val="BFBFBF"/>
+                      </a:solidFill>
+                      <a:prstDash val="solid"/>
+                      <a:round/>
+                      <a:headEnd type="none" w="med" len="med"/>
+                      <a:tailEnd type="none" w="med" len="med"/>
+                    </a:lnR>
+                    <a:lnT w="9525" cap="flat" cmpd="sng" algn="ctr">
+                      <a:solidFill>
+                        <a:srgbClr val="BFBFBF"/>
+                      </a:solidFill>
+                      <a:prstDash val="solid"/>
+                      <a:round/>
+                      <a:headEnd type="none" w="med" len="med"/>
+                      <a:tailEnd type="none" w="med" len="med"/>
+                    </a:lnT>
+                    <a:lnB w="9525" cap="flat" cmpd="sng" algn="ctr">
+                      <a:solidFill>
+                        <a:srgbClr val="BFBFBF"/>
+                      </a:solidFill>
+                      <a:prstDash val="solid"/>
+                      <a:round/>
+                      <a:headEnd type="none" w="med" len="med"/>
+                      <a:tailEnd type="none" w="med" len="med"/>
+                    </a:lnB>
+                    <a:solidFill>
+                      <a:srgbClr val="EAF0F8"/>
                     </a:solidFill>
                   </a:tcPr>
                 </a:tc>
@@ -2114,18 +2107,7 @@
                       <a:pPr algn="ctr" indent="0" marL="0">
                         <a:buNone/>
                       </a:pPr>
-                      <a:r>
-                        <a:rPr lang="en-US" sz="1200" i="1" dirty="0">
-                          <a:solidFill>
-                            <a:srgbClr val="FFFFFF"/>
-                          </a:solidFill>
-                          <a:latin typeface="맑은 고딕" pitchFamily="34" charset="0"/>
-                          <a:ea typeface="맑은 고딕" pitchFamily="34" charset="-122"/>
-                          <a:cs typeface="맑은 고딕" pitchFamily="34" charset="-120"/>
-                        </a:rPr>
-                        <a:t>협업</a:t>
-                      </a:r>
-                      <a:endParaRPr lang="en-US" sz="1200" dirty="0">
+                      <a:endParaRPr lang="en-US" sz="1150" dirty="0">
                         <a:latin typeface="맑은 고딕" charset="0"/>
                         <a:ea typeface="맑은 고딕" charset="0"/>
                         <a:cs typeface="맑은 고딕" charset="0"/>
@@ -2135,42 +2117,42 @@
                   <a:tcPr marL="91440" marR="91440" marT="45720" marB="45720" anchor="ctr">
                     <a:lnL w="9525" cap="flat" cmpd="sng" algn="ctr">
                       <a:solidFill>
-                        <a:srgbClr val="FFFFFF"/>
-                      </a:solidFill>
-                      <a:prstDash val="solid"/>
-                      <a:round/>
-                      <a:headEnd type="none" w="med" len="med"/>
-                      <a:tailEnd type="none" w="med" len="med"/>
-                    </a:lnL>
-                    <a:lnR w="9525" cap="flat" cmpd="sng" algn="ctr">
-                      <a:solidFill>
-                        <a:srgbClr val="FFFFFF"/>
-                      </a:solidFill>
-                      <a:prstDash val="solid"/>
-                      <a:round/>
-                      <a:headEnd type="none" w="med" len="med"/>
-                      <a:tailEnd type="none" w="med" len="med"/>
-                    </a:lnR>
-                    <a:lnT w="9525" cap="flat" cmpd="sng" algn="ctr">
-                      <a:solidFill>
-                        <a:srgbClr val="FFFFFF"/>
-                      </a:solidFill>
-                      <a:prstDash val="solid"/>
-                      <a:round/>
-                      <a:headEnd type="none" w="med" len="med"/>
-                      <a:tailEnd type="none" w="med" len="med"/>
-                    </a:lnT>
-                    <a:lnB w="9525" cap="flat" cmpd="sng" algn="ctr">
-                      <a:solidFill>
-                        <a:srgbClr val="FFFFFF"/>
-                      </a:solidFill>
-                      <a:prstDash val="solid"/>
-                      <a:round/>
-                      <a:headEnd type="none" w="med" len="med"/>
-                      <a:tailEnd type="none" w="med" len="med"/>
-                    </a:lnB>
-                    <a:solidFill>
-                      <a:srgbClr val="5B8ED6"/>
+                        <a:srgbClr val="BFBFBF"/>
+                      </a:solidFill>
+                      <a:prstDash val="solid"/>
+                      <a:round/>
+                      <a:headEnd type="none" w="med" len="med"/>
+                      <a:tailEnd type="none" w="med" len="med"/>
+                    </a:lnL>
+                    <a:lnR w="9525" cap="flat" cmpd="sng" algn="ctr">
+                      <a:solidFill>
+                        <a:srgbClr val="BFBFBF"/>
+                      </a:solidFill>
+                      <a:prstDash val="solid"/>
+                      <a:round/>
+                      <a:headEnd type="none" w="med" len="med"/>
+                      <a:tailEnd type="none" w="med" len="med"/>
+                    </a:lnR>
+                    <a:lnT w="9525" cap="flat" cmpd="sng" algn="ctr">
+                      <a:solidFill>
+                        <a:srgbClr val="BFBFBF"/>
+                      </a:solidFill>
+                      <a:prstDash val="solid"/>
+                      <a:round/>
+                      <a:headEnd type="none" w="med" len="med"/>
+                      <a:tailEnd type="none" w="med" len="med"/>
+                    </a:lnT>
+                    <a:lnB w="9525" cap="flat" cmpd="sng" algn="ctr">
+                      <a:solidFill>
+                        <a:srgbClr val="BFBFBF"/>
+                      </a:solidFill>
+                      <a:prstDash val="solid"/>
+                      <a:round/>
+                      <a:headEnd type="none" w="med" len="med"/>
+                      <a:tailEnd type="none" w="med" len="med"/>
+                    </a:lnB>
+                    <a:solidFill>
+                      <a:srgbClr val="FFFFFF"/>
                     </a:solidFill>
                   </a:tcPr>
                 </a:tc>
@@ -2473,18 +2455,7 @@
                       <a:pPr algn="ctr" indent="0" marL="0">
                         <a:buNone/>
                       </a:pPr>
-                      <a:r>
-                        <a:rPr lang="en-US" sz="1200" i="1" dirty="0">
-                          <a:solidFill>
-                            <a:srgbClr val="FFFFFF"/>
-                          </a:solidFill>
-                          <a:latin typeface="맑은 고딕" pitchFamily="34" charset="0"/>
-                          <a:ea typeface="맑은 고딕" pitchFamily="34" charset="-122"/>
-                          <a:cs typeface="맑은 고딕" pitchFamily="34" charset="-120"/>
-                        </a:rPr>
-                        <a:t>협업</a:t>
-                      </a:r>
-                      <a:endParaRPr lang="en-US" sz="1200" dirty="0">
+                      <a:endParaRPr lang="en-US" sz="1150" dirty="0">
                         <a:latin typeface="맑은 고딕" charset="0"/>
                         <a:ea typeface="맑은 고딕" charset="0"/>
                         <a:cs typeface="맑은 고딕" charset="0"/>
@@ -2494,42 +2465,42 @@
                   <a:tcPr marL="91440" marR="91440" marT="45720" marB="45720" anchor="ctr">
                     <a:lnL w="9525" cap="flat" cmpd="sng" algn="ctr">
                       <a:solidFill>
-                        <a:srgbClr val="FFFFFF"/>
-                      </a:solidFill>
-                      <a:prstDash val="solid"/>
-                      <a:round/>
-                      <a:headEnd type="none" w="med" len="med"/>
-                      <a:tailEnd type="none" w="med" len="med"/>
-                    </a:lnL>
-                    <a:lnR w="9525" cap="flat" cmpd="sng" algn="ctr">
-                      <a:solidFill>
-                        <a:srgbClr val="FFFFFF"/>
-                      </a:solidFill>
-                      <a:prstDash val="solid"/>
-                      <a:round/>
-                      <a:headEnd type="none" w="med" len="med"/>
-                      <a:tailEnd type="none" w="med" len="med"/>
-                    </a:lnR>
-                    <a:lnT w="9525" cap="flat" cmpd="sng" algn="ctr">
-                      <a:solidFill>
-                        <a:srgbClr val="FFFFFF"/>
-                      </a:solidFill>
-                      <a:prstDash val="solid"/>
-                      <a:round/>
-                      <a:headEnd type="none" w="med" len="med"/>
-                      <a:tailEnd type="none" w="med" len="med"/>
-                    </a:lnT>
-                    <a:lnB w="9525" cap="flat" cmpd="sng" algn="ctr">
-                      <a:solidFill>
-                        <a:srgbClr val="FFFFFF"/>
-                      </a:solidFill>
-                      <a:prstDash val="solid"/>
-                      <a:round/>
-                      <a:headEnd type="none" w="med" len="med"/>
-                      <a:tailEnd type="none" w="med" len="med"/>
-                    </a:lnB>
-                    <a:solidFill>
-                      <a:srgbClr val="5B8ED6"/>
+                        <a:srgbClr val="BFBFBF"/>
+                      </a:solidFill>
+                      <a:prstDash val="solid"/>
+                      <a:round/>
+                      <a:headEnd type="none" w="med" len="med"/>
+                      <a:tailEnd type="none" w="med" len="med"/>
+                    </a:lnL>
+                    <a:lnR w="9525" cap="flat" cmpd="sng" algn="ctr">
+                      <a:solidFill>
+                        <a:srgbClr val="BFBFBF"/>
+                      </a:solidFill>
+                      <a:prstDash val="solid"/>
+                      <a:round/>
+                      <a:headEnd type="none" w="med" len="med"/>
+                      <a:tailEnd type="none" w="med" len="med"/>
+                    </a:lnR>
+                    <a:lnT w="9525" cap="flat" cmpd="sng" algn="ctr">
+                      <a:solidFill>
+                        <a:srgbClr val="BFBFBF"/>
+                      </a:solidFill>
+                      <a:prstDash val="solid"/>
+                      <a:round/>
+                      <a:headEnd type="none" w="med" len="med"/>
+                      <a:tailEnd type="none" w="med" len="med"/>
+                    </a:lnT>
+                    <a:lnB w="9525" cap="flat" cmpd="sng" algn="ctr">
+                      <a:solidFill>
+                        <a:srgbClr val="BFBFBF"/>
+                      </a:solidFill>
+                      <a:prstDash val="solid"/>
+                      <a:round/>
+                      <a:headEnd type="none" w="med" len="med"/>
+                      <a:tailEnd type="none" w="med" len="med"/>
+                    </a:lnB>
+                    <a:solidFill>
+                      <a:srgbClr val="FFFFFF"/>
                     </a:solidFill>
                   </a:tcPr>
                 </a:tc>
@@ -2894,17 +2865,17 @@
                         <a:buNone/>
                       </a:pPr>
                       <a:r>
-                        <a:rPr lang="en-US" sz="1200" i="1" dirty="0">
-                          <a:solidFill>
-                            <a:srgbClr val="FFFFFF"/>
-                          </a:solidFill>
-                          <a:latin typeface="맑은 고딕" pitchFamily="34" charset="0"/>
-                          <a:ea typeface="맑은 고딕" pitchFamily="34" charset="-122"/>
-                          <a:cs typeface="맑은 고딕" pitchFamily="34" charset="-120"/>
-                        </a:rPr>
-                        <a:t>협업</a:t>
-                      </a:r>
-                      <a:endParaRPr lang="en-US" sz="1200" dirty="0">
+                        <a:rPr lang="en-US" sz="1150" b="1" dirty="0">
+                          <a:solidFill>
+                            <a:srgbClr val="1F3F6E"/>
+                          </a:solidFill>
+                          <a:latin typeface="맑은 고딕" pitchFamily="34" charset="0"/>
+                          <a:ea typeface="맑은 고딕" pitchFamily="34" charset="-122"/>
+                          <a:cs typeface="맑은 고딕" pitchFamily="34" charset="-120"/>
+                        </a:rPr>
+                        <a:t>업무 흐름 설명</a:t>
+                      </a:r>
+                      <a:endParaRPr lang="en-US" sz="1150" dirty="0">
                         <a:latin typeface="맑은 고딕" charset="0"/>
                         <a:ea typeface="맑은 고딕" charset="0"/>
                         <a:cs typeface="맑은 고딕" charset="0"/>
@@ -2914,42 +2885,42 @@
                   <a:tcPr marL="91440" marR="91440" marT="45720" marB="45720" anchor="ctr">
                     <a:lnL w="9525" cap="flat" cmpd="sng" algn="ctr">
                       <a:solidFill>
-                        <a:srgbClr val="FFFFFF"/>
-                      </a:solidFill>
-                      <a:prstDash val="solid"/>
-                      <a:round/>
-                      <a:headEnd type="none" w="med" len="med"/>
-                      <a:tailEnd type="none" w="med" len="med"/>
-                    </a:lnL>
-                    <a:lnR w="9525" cap="flat" cmpd="sng" algn="ctr">
-                      <a:solidFill>
-                        <a:srgbClr val="FFFFFF"/>
-                      </a:solidFill>
-                      <a:prstDash val="solid"/>
-                      <a:round/>
-                      <a:headEnd type="none" w="med" len="med"/>
-                      <a:tailEnd type="none" w="med" len="med"/>
-                    </a:lnR>
-                    <a:lnT w="9525" cap="flat" cmpd="sng" algn="ctr">
-                      <a:solidFill>
-                        <a:srgbClr val="FFFFFF"/>
-                      </a:solidFill>
-                      <a:prstDash val="solid"/>
-                      <a:round/>
-                      <a:headEnd type="none" w="med" len="med"/>
-                      <a:tailEnd type="none" w="med" len="med"/>
-                    </a:lnT>
-                    <a:lnB w="9525" cap="flat" cmpd="sng" algn="ctr">
-                      <a:solidFill>
-                        <a:srgbClr val="FFFFFF"/>
-                      </a:solidFill>
-                      <a:prstDash val="solid"/>
-                      <a:round/>
-                      <a:headEnd type="none" w="med" len="med"/>
-                      <a:tailEnd type="none" w="med" len="med"/>
-                    </a:lnB>
-                    <a:solidFill>
-                      <a:srgbClr val="5B8ED6"/>
+                        <a:srgbClr val="BFBFBF"/>
+                      </a:solidFill>
+                      <a:prstDash val="solid"/>
+                      <a:round/>
+                      <a:headEnd type="none" w="med" len="med"/>
+                      <a:tailEnd type="none" w="med" len="med"/>
+                    </a:lnL>
+                    <a:lnR w="9525" cap="flat" cmpd="sng" algn="ctr">
+                      <a:solidFill>
+                        <a:srgbClr val="BFBFBF"/>
+                      </a:solidFill>
+                      <a:prstDash val="solid"/>
+                      <a:round/>
+                      <a:headEnd type="none" w="med" len="med"/>
+                      <a:tailEnd type="none" w="med" len="med"/>
+                    </a:lnR>
+                    <a:lnT w="9525" cap="flat" cmpd="sng" algn="ctr">
+                      <a:solidFill>
+                        <a:srgbClr val="BFBFBF"/>
+                      </a:solidFill>
+                      <a:prstDash val="solid"/>
+                      <a:round/>
+                      <a:headEnd type="none" w="med" len="med"/>
+                      <a:tailEnd type="none" w="med" len="med"/>
+                    </a:lnT>
+                    <a:lnB w="9525" cap="flat" cmpd="sng" algn="ctr">
+                      <a:solidFill>
+                        <a:srgbClr val="BFBFBF"/>
+                      </a:solidFill>
+                      <a:prstDash val="solid"/>
+                      <a:round/>
+                      <a:headEnd type="none" w="med" len="med"/>
+                      <a:tailEnd type="none" w="med" len="med"/>
+                    </a:lnB>
+                    <a:solidFill>
+                      <a:srgbClr val="EAF0F8"/>
                     </a:solidFill>
                   </a:tcPr>
                 </a:tc>
@@ -3252,18 +3223,7 @@
                       <a:pPr algn="ctr" indent="0" marL="0">
                         <a:buNone/>
                       </a:pPr>
-                      <a:r>
-                        <a:rPr lang="en-US" sz="1200" i="1" dirty="0">
-                          <a:solidFill>
-                            <a:srgbClr val="FFFFFF"/>
-                          </a:solidFill>
-                          <a:latin typeface="맑은 고딕" pitchFamily="34" charset="0"/>
-                          <a:ea typeface="맑은 고딕" pitchFamily="34" charset="-122"/>
-                          <a:cs typeface="맑은 고딕" pitchFamily="34" charset="-120"/>
-                        </a:rPr>
-                        <a:t>협업</a:t>
-                      </a:r>
-                      <a:endParaRPr lang="en-US" sz="1200" dirty="0">
+                      <a:endParaRPr lang="en-US" sz="1150" dirty="0">
                         <a:latin typeface="맑은 고딕" charset="0"/>
                         <a:ea typeface="맑은 고딕" charset="0"/>
                         <a:cs typeface="맑은 고딕" charset="0"/>
@@ -3273,42 +3233,42 @@
                   <a:tcPr marL="91440" marR="91440" marT="45720" marB="45720" anchor="ctr">
                     <a:lnL w="9525" cap="flat" cmpd="sng" algn="ctr">
                       <a:solidFill>
-                        <a:srgbClr val="FFFFFF"/>
-                      </a:solidFill>
-                      <a:prstDash val="solid"/>
-                      <a:round/>
-                      <a:headEnd type="none" w="med" len="med"/>
-                      <a:tailEnd type="none" w="med" len="med"/>
-                    </a:lnL>
-                    <a:lnR w="9525" cap="flat" cmpd="sng" algn="ctr">
-                      <a:solidFill>
-                        <a:srgbClr val="FFFFFF"/>
-                      </a:solidFill>
-                      <a:prstDash val="solid"/>
-                      <a:round/>
-                      <a:headEnd type="none" w="med" len="med"/>
-                      <a:tailEnd type="none" w="med" len="med"/>
-                    </a:lnR>
-                    <a:lnT w="9525" cap="flat" cmpd="sng" algn="ctr">
-                      <a:solidFill>
-                        <a:srgbClr val="FFFFFF"/>
-                      </a:solidFill>
-                      <a:prstDash val="solid"/>
-                      <a:round/>
-                      <a:headEnd type="none" w="med" len="med"/>
-                      <a:tailEnd type="none" w="med" len="med"/>
-                    </a:lnT>
-                    <a:lnB w="9525" cap="flat" cmpd="sng" algn="ctr">
-                      <a:solidFill>
-                        <a:srgbClr val="FFFFFF"/>
-                      </a:solidFill>
-                      <a:prstDash val="solid"/>
-                      <a:round/>
-                      <a:headEnd type="none" w="med" len="med"/>
-                      <a:tailEnd type="none" w="med" len="med"/>
-                    </a:lnB>
-                    <a:solidFill>
-                      <a:srgbClr val="5B8ED6"/>
+                        <a:srgbClr val="BFBFBF"/>
+                      </a:solidFill>
+                      <a:prstDash val="solid"/>
+                      <a:round/>
+                      <a:headEnd type="none" w="med" len="med"/>
+                      <a:tailEnd type="none" w="med" len="med"/>
+                    </a:lnL>
+                    <a:lnR w="9525" cap="flat" cmpd="sng" algn="ctr">
+                      <a:solidFill>
+                        <a:srgbClr val="BFBFBF"/>
+                      </a:solidFill>
+                      <a:prstDash val="solid"/>
+                      <a:round/>
+                      <a:headEnd type="none" w="med" len="med"/>
+                      <a:tailEnd type="none" w="med" len="med"/>
+                    </a:lnR>
+                    <a:lnT w="9525" cap="flat" cmpd="sng" algn="ctr">
+                      <a:solidFill>
+                        <a:srgbClr val="BFBFBF"/>
+                      </a:solidFill>
+                      <a:prstDash val="solid"/>
+                      <a:round/>
+                      <a:headEnd type="none" w="med" len="med"/>
+                      <a:tailEnd type="none" w="med" len="med"/>
+                    </a:lnT>
+                    <a:lnB w="9525" cap="flat" cmpd="sng" algn="ctr">
+                      <a:solidFill>
+                        <a:srgbClr val="BFBFBF"/>
+                      </a:solidFill>
+                      <a:prstDash val="solid"/>
+                      <a:round/>
+                      <a:headEnd type="none" w="med" len="med"/>
+                      <a:tailEnd type="none" w="med" len="med"/>
+                    </a:lnB>
+                    <a:solidFill>
+                      <a:srgbClr val="FFFFFF"/>
                     </a:solidFill>
                   </a:tcPr>
                 </a:tc>
@@ -3597,18 +3557,7 @@
                       <a:pPr algn="ctr" indent="0" marL="0">
                         <a:buNone/>
                       </a:pPr>
-                      <a:r>
-                        <a:rPr lang="en-US" sz="1200" i="1" dirty="0">
-                          <a:solidFill>
-                            <a:srgbClr val="8C8C8C"/>
-                          </a:solidFill>
-                          <a:latin typeface="맑은 고딕" pitchFamily="34" charset="0"/>
-                          <a:ea typeface="맑은 고딕" pitchFamily="34" charset="-122"/>
-                          <a:cs typeface="맑은 고딕" pitchFamily="34" charset="-120"/>
-                        </a:rPr>
-                        <a:t>지원</a:t>
-                      </a:r>
-                      <a:endParaRPr lang="en-US" sz="1200" dirty="0">
+                      <a:endParaRPr lang="en-US" sz="1150" dirty="0">
                         <a:latin typeface="맑은 고딕" charset="0"/>
                         <a:ea typeface="맑은 고딕" charset="0"/>
                         <a:cs typeface="맑은 고딕" charset="0"/>
@@ -3618,42 +3567,42 @@
                   <a:tcPr marL="91440" marR="91440" marT="45720" marB="45720" anchor="ctr">
                     <a:lnL w="9525" cap="flat" cmpd="sng" algn="ctr">
                       <a:solidFill>
-                        <a:srgbClr val="FFFFFF"/>
-                      </a:solidFill>
-                      <a:prstDash val="solid"/>
-                      <a:round/>
-                      <a:headEnd type="none" w="med" len="med"/>
-                      <a:tailEnd type="none" w="med" len="med"/>
-                    </a:lnL>
-                    <a:lnR w="9525" cap="flat" cmpd="sng" algn="ctr">
-                      <a:solidFill>
-                        <a:srgbClr val="FFFFFF"/>
-                      </a:solidFill>
-                      <a:prstDash val="solid"/>
-                      <a:round/>
-                      <a:headEnd type="none" w="med" len="med"/>
-                      <a:tailEnd type="none" w="med" len="med"/>
-                    </a:lnR>
-                    <a:lnT w="9525" cap="flat" cmpd="sng" algn="ctr">
-                      <a:solidFill>
-                        <a:srgbClr val="FFFFFF"/>
-                      </a:solidFill>
-                      <a:prstDash val="solid"/>
-                      <a:round/>
-                      <a:headEnd type="none" w="med" len="med"/>
-                      <a:tailEnd type="none" w="med" len="med"/>
-                    </a:lnT>
-                    <a:lnB w="9525" cap="flat" cmpd="sng" algn="ctr">
-                      <a:solidFill>
-                        <a:srgbClr val="FFFFFF"/>
-                      </a:solidFill>
-                      <a:prstDash val="solid"/>
-                      <a:round/>
-                      <a:headEnd type="none" w="med" len="med"/>
-                      <a:tailEnd type="none" w="med" len="med"/>
-                    </a:lnB>
-                    <a:solidFill>
-                      <a:srgbClr val="DCE5F1"/>
+                        <a:srgbClr val="BFBFBF"/>
+                      </a:solidFill>
+                      <a:prstDash val="solid"/>
+                      <a:round/>
+                      <a:headEnd type="none" w="med" len="med"/>
+                      <a:tailEnd type="none" w="med" len="med"/>
+                    </a:lnL>
+                    <a:lnR w="9525" cap="flat" cmpd="sng" algn="ctr">
+                      <a:solidFill>
+                        <a:srgbClr val="BFBFBF"/>
+                      </a:solidFill>
+                      <a:prstDash val="solid"/>
+                      <a:round/>
+                      <a:headEnd type="none" w="med" len="med"/>
+                      <a:tailEnd type="none" w="med" len="med"/>
+                    </a:lnR>
+                    <a:lnT w="9525" cap="flat" cmpd="sng" algn="ctr">
+                      <a:solidFill>
+                        <a:srgbClr val="BFBFBF"/>
+                      </a:solidFill>
+                      <a:prstDash val="solid"/>
+                      <a:round/>
+                      <a:headEnd type="none" w="med" len="med"/>
+                      <a:tailEnd type="none" w="med" len="med"/>
+                    </a:lnT>
+                    <a:lnB w="9525" cap="flat" cmpd="sng" algn="ctr">
+                      <a:solidFill>
+                        <a:srgbClr val="BFBFBF"/>
+                      </a:solidFill>
+                      <a:prstDash val="solid"/>
+                      <a:round/>
+                      <a:headEnd type="none" w="med" len="med"/>
+                      <a:tailEnd type="none" w="med" len="med"/>
+                    </a:lnB>
+                    <a:solidFill>
+                      <a:srgbClr val="FFFFFF"/>
                     </a:solidFill>
                   </a:tcPr>
                 </a:tc>
@@ -4043,17 +3992,17 @@
                         <a:buNone/>
                       </a:pPr>
                       <a:r>
-                        <a:rPr lang="en-US" sz="1200" i="1" dirty="0">
-                          <a:solidFill>
-                            <a:srgbClr val="8C8C8C"/>
-                          </a:solidFill>
-                          <a:latin typeface="맑은 고딕" pitchFamily="34" charset="0"/>
-                          <a:ea typeface="맑은 고딕" pitchFamily="34" charset="-122"/>
-                          <a:cs typeface="맑은 고딕" pitchFamily="34" charset="-120"/>
-                        </a:rPr>
-                        <a:t>지원</a:t>
-                      </a:r>
-                      <a:endParaRPr lang="en-US" sz="1200" dirty="0">
+                        <a:rPr lang="en-US" sz="1150" b="1" dirty="0">
+                          <a:solidFill>
+                            <a:srgbClr val="1F3F6E"/>
+                          </a:solidFill>
+                          <a:latin typeface="맑은 고딕" pitchFamily="34" charset="0"/>
+                          <a:ea typeface="맑은 고딕" pitchFamily="34" charset="-122"/>
+                          <a:cs typeface="맑은 고딕" pitchFamily="34" charset="-120"/>
+                        </a:rPr>
+                        <a:t>업무 데이터 제공</a:t>
+                      </a:r>
+                      <a:endParaRPr lang="en-US" sz="1150" dirty="0">
                         <a:latin typeface="맑은 고딕" charset="0"/>
                         <a:ea typeface="맑은 고딕" charset="0"/>
                         <a:cs typeface="맑은 고딕" charset="0"/>
@@ -4063,42 +4012,42 @@
                   <a:tcPr marL="91440" marR="91440" marT="45720" marB="45720" anchor="ctr">
                     <a:lnL w="9525" cap="flat" cmpd="sng" algn="ctr">
                       <a:solidFill>
-                        <a:srgbClr val="FFFFFF"/>
-                      </a:solidFill>
-                      <a:prstDash val="solid"/>
-                      <a:round/>
-                      <a:headEnd type="none" w="med" len="med"/>
-                      <a:tailEnd type="none" w="med" len="med"/>
-                    </a:lnL>
-                    <a:lnR w="9525" cap="flat" cmpd="sng" algn="ctr">
-                      <a:solidFill>
-                        <a:srgbClr val="FFFFFF"/>
-                      </a:solidFill>
-                      <a:prstDash val="solid"/>
-                      <a:round/>
-                      <a:headEnd type="none" w="med" len="med"/>
-                      <a:tailEnd type="none" w="med" len="med"/>
-                    </a:lnR>
-                    <a:lnT w="9525" cap="flat" cmpd="sng" algn="ctr">
-                      <a:solidFill>
-                        <a:srgbClr val="FFFFFF"/>
-                      </a:solidFill>
-                      <a:prstDash val="solid"/>
-                      <a:round/>
-                      <a:headEnd type="none" w="med" len="med"/>
-                      <a:tailEnd type="none" w="med" len="med"/>
-                    </a:lnT>
-                    <a:lnB w="9525" cap="flat" cmpd="sng" algn="ctr">
-                      <a:solidFill>
-                        <a:srgbClr val="FFFFFF"/>
-                      </a:solidFill>
-                      <a:prstDash val="solid"/>
-                      <a:round/>
-                      <a:headEnd type="none" w="med" len="med"/>
-                      <a:tailEnd type="none" w="med" len="med"/>
-                    </a:lnB>
-                    <a:solidFill>
-                      <a:srgbClr val="DCE5F1"/>
+                        <a:srgbClr val="BFBFBF"/>
+                      </a:solidFill>
+                      <a:prstDash val="solid"/>
+                      <a:round/>
+                      <a:headEnd type="none" w="med" len="med"/>
+                      <a:tailEnd type="none" w="med" len="med"/>
+                    </a:lnL>
+                    <a:lnR w="9525" cap="flat" cmpd="sng" algn="ctr">
+                      <a:solidFill>
+                        <a:srgbClr val="BFBFBF"/>
+                      </a:solidFill>
+                      <a:prstDash val="solid"/>
+                      <a:round/>
+                      <a:headEnd type="none" w="med" len="med"/>
+                      <a:tailEnd type="none" w="med" len="med"/>
+                    </a:lnR>
+                    <a:lnT w="9525" cap="flat" cmpd="sng" algn="ctr">
+                      <a:solidFill>
+                        <a:srgbClr val="BFBFBF"/>
+                      </a:solidFill>
+                      <a:prstDash val="solid"/>
+                      <a:round/>
+                      <a:headEnd type="none" w="med" len="med"/>
+                      <a:tailEnd type="none" w="med" len="med"/>
+                    </a:lnT>
+                    <a:lnB w="9525" cap="flat" cmpd="sng" algn="ctr">
+                      <a:solidFill>
+                        <a:srgbClr val="BFBFBF"/>
+                      </a:solidFill>
+                      <a:prstDash val="solid"/>
+                      <a:round/>
+                      <a:headEnd type="none" w="med" len="med"/>
+                      <a:tailEnd type="none" w="med" len="med"/>
+                    </a:lnB>
+                    <a:solidFill>
+                      <a:srgbClr val="EAF0F8"/>
                     </a:solidFill>
                   </a:tcPr>
                 </a:tc>
@@ -4377,17 +4326,17 @@
                         <a:buNone/>
                       </a:pPr>
                       <a:r>
-                        <a:rPr lang="en-US" sz="1200" i="1" dirty="0">
-                          <a:solidFill>
-                            <a:srgbClr val="FFFFFF"/>
-                          </a:solidFill>
-                          <a:latin typeface="맑은 고딕" pitchFamily="34" charset="0"/>
-                          <a:ea typeface="맑은 고딕" pitchFamily="34" charset="-122"/>
-                          <a:cs typeface="맑은 고딕" pitchFamily="34" charset="-120"/>
-                        </a:rPr>
-                        <a:t>협업</a:t>
-                      </a:r>
-                      <a:endParaRPr lang="en-US" sz="1200" dirty="0">
+                        <a:rPr lang="en-US" sz="1150" b="1" dirty="0">
+                          <a:solidFill>
+                            <a:srgbClr val="1F3F6E"/>
+                          </a:solidFill>
+                          <a:latin typeface="맑은 고딕" pitchFamily="34" charset="0"/>
+                          <a:ea typeface="맑은 고딕" pitchFamily="34" charset="-122"/>
+                          <a:cs typeface="맑은 고딕" pitchFamily="34" charset="-120"/>
+                        </a:rPr>
+                        <a:t>과제 Owner 지정</a:t>
+                      </a:r>
+                      <a:endParaRPr lang="en-US" sz="1150" dirty="0">
                         <a:latin typeface="맑은 고딕" charset="0"/>
                         <a:ea typeface="맑은 고딕" charset="0"/>
                         <a:cs typeface="맑은 고딕" charset="0"/>
@@ -4397,42 +4346,42 @@
                   <a:tcPr marL="91440" marR="91440" marT="45720" marB="45720" anchor="ctr">
                     <a:lnL w="9525" cap="flat" cmpd="sng" algn="ctr">
                       <a:solidFill>
-                        <a:srgbClr val="FFFFFF"/>
-                      </a:solidFill>
-                      <a:prstDash val="solid"/>
-                      <a:round/>
-                      <a:headEnd type="none" w="med" len="med"/>
-                      <a:tailEnd type="none" w="med" len="med"/>
-                    </a:lnL>
-                    <a:lnR w="9525" cap="flat" cmpd="sng" algn="ctr">
-                      <a:solidFill>
-                        <a:srgbClr val="FFFFFF"/>
-                      </a:solidFill>
-                      <a:prstDash val="solid"/>
-                      <a:round/>
-                      <a:headEnd type="none" w="med" len="med"/>
-                      <a:tailEnd type="none" w="med" len="med"/>
-                    </a:lnR>
-                    <a:lnT w="9525" cap="flat" cmpd="sng" algn="ctr">
-                      <a:solidFill>
-                        <a:srgbClr val="FFFFFF"/>
-                      </a:solidFill>
-                      <a:prstDash val="solid"/>
-                      <a:round/>
-                      <a:headEnd type="none" w="med" len="med"/>
-                      <a:tailEnd type="none" w="med" len="med"/>
-                    </a:lnT>
-                    <a:lnB w="9525" cap="flat" cmpd="sng" algn="ctr">
-                      <a:solidFill>
-                        <a:srgbClr val="FFFFFF"/>
-                      </a:solidFill>
-                      <a:prstDash val="solid"/>
-                      <a:round/>
-                      <a:headEnd type="none" w="med" len="med"/>
-                      <a:tailEnd type="none" w="med" len="med"/>
-                    </a:lnB>
-                    <a:solidFill>
-                      <a:srgbClr val="5B8ED6"/>
+                        <a:srgbClr val="BFBFBF"/>
+                      </a:solidFill>
+                      <a:prstDash val="solid"/>
+                      <a:round/>
+                      <a:headEnd type="none" w="med" len="med"/>
+                      <a:tailEnd type="none" w="med" len="med"/>
+                    </a:lnL>
+                    <a:lnR w="9525" cap="flat" cmpd="sng" algn="ctr">
+                      <a:solidFill>
+                        <a:srgbClr val="BFBFBF"/>
+                      </a:solidFill>
+                      <a:prstDash val="solid"/>
+                      <a:round/>
+                      <a:headEnd type="none" w="med" len="med"/>
+                      <a:tailEnd type="none" w="med" len="med"/>
+                    </a:lnR>
+                    <a:lnT w="9525" cap="flat" cmpd="sng" algn="ctr">
+                      <a:solidFill>
+                        <a:srgbClr val="BFBFBF"/>
+                      </a:solidFill>
+                      <a:prstDash val="solid"/>
+                      <a:round/>
+                      <a:headEnd type="none" w="med" len="med"/>
+                      <a:tailEnd type="none" w="med" len="med"/>
+                    </a:lnT>
+                    <a:lnB w="9525" cap="flat" cmpd="sng" algn="ctr">
+                      <a:solidFill>
+                        <a:srgbClr val="BFBFBF"/>
+                      </a:solidFill>
+                      <a:prstDash val="solid"/>
+                      <a:round/>
+                      <a:headEnd type="none" w="med" len="med"/>
+                      <a:tailEnd type="none" w="med" len="med"/>
+                    </a:lnB>
+                    <a:solidFill>
+                      <a:srgbClr val="EAF0F8"/>
                     </a:solidFill>
                   </a:tcPr>
                 </a:tc>
@@ -4721,18 +4670,7 @@
                       <a:pPr algn="ctr" indent="0" marL="0">
                         <a:buNone/>
                       </a:pPr>
-                      <a:r>
-                        <a:rPr lang="en-US" sz="1200" i="1" dirty="0">
-                          <a:solidFill>
-                            <a:srgbClr val="FFFFFF"/>
-                          </a:solidFill>
-                          <a:latin typeface="맑은 고딕" pitchFamily="34" charset="0"/>
-                          <a:ea typeface="맑은 고딕" pitchFamily="34" charset="-122"/>
-                          <a:cs typeface="맑은 고딕" pitchFamily="34" charset="-120"/>
-                        </a:rPr>
-                        <a:t>협업</a:t>
-                      </a:r>
-                      <a:endParaRPr lang="en-US" sz="1200" dirty="0">
+                      <a:endParaRPr lang="en-US" sz="1150" dirty="0">
                         <a:latin typeface="맑은 고딕" charset="0"/>
                         <a:ea typeface="맑은 고딕" charset="0"/>
                         <a:cs typeface="맑은 고딕" charset="0"/>
@@ -4742,42 +4680,42 @@
                   <a:tcPr marL="91440" marR="91440" marT="45720" marB="45720" anchor="ctr">
                     <a:lnL w="9525" cap="flat" cmpd="sng" algn="ctr">
                       <a:solidFill>
-                        <a:srgbClr val="FFFFFF"/>
-                      </a:solidFill>
-                      <a:prstDash val="solid"/>
-                      <a:round/>
-                      <a:headEnd type="none" w="med" len="med"/>
-                      <a:tailEnd type="none" w="med" len="med"/>
-                    </a:lnL>
-                    <a:lnR w="9525" cap="flat" cmpd="sng" algn="ctr">
-                      <a:solidFill>
-                        <a:srgbClr val="FFFFFF"/>
-                      </a:solidFill>
-                      <a:prstDash val="solid"/>
-                      <a:round/>
-                      <a:headEnd type="none" w="med" len="med"/>
-                      <a:tailEnd type="none" w="med" len="med"/>
-                    </a:lnR>
-                    <a:lnT w="9525" cap="flat" cmpd="sng" algn="ctr">
-                      <a:solidFill>
-                        <a:srgbClr val="FFFFFF"/>
-                      </a:solidFill>
-                      <a:prstDash val="solid"/>
-                      <a:round/>
-                      <a:headEnd type="none" w="med" len="med"/>
-                      <a:tailEnd type="none" w="med" len="med"/>
-                    </a:lnT>
-                    <a:lnB w="9525" cap="flat" cmpd="sng" algn="ctr">
-                      <a:solidFill>
-                        <a:srgbClr val="FFFFFF"/>
-                      </a:solidFill>
-                      <a:prstDash val="solid"/>
-                      <a:round/>
-                      <a:headEnd type="none" w="med" len="med"/>
-                      <a:tailEnd type="none" w="med" len="med"/>
-                    </a:lnB>
-                    <a:solidFill>
-                      <a:srgbClr val="5B8ED6"/>
+                        <a:srgbClr val="BFBFBF"/>
+                      </a:solidFill>
+                      <a:prstDash val="solid"/>
+                      <a:round/>
+                      <a:headEnd type="none" w="med" len="med"/>
+                      <a:tailEnd type="none" w="med" len="med"/>
+                    </a:lnL>
+                    <a:lnR w="9525" cap="flat" cmpd="sng" algn="ctr">
+                      <a:solidFill>
+                        <a:srgbClr val="BFBFBF"/>
+                      </a:solidFill>
+                      <a:prstDash val="solid"/>
+                      <a:round/>
+                      <a:headEnd type="none" w="med" len="med"/>
+                      <a:tailEnd type="none" w="med" len="med"/>
+                    </a:lnR>
+                    <a:lnT w="9525" cap="flat" cmpd="sng" algn="ctr">
+                      <a:solidFill>
+                        <a:srgbClr val="BFBFBF"/>
+                      </a:solidFill>
+                      <a:prstDash val="solid"/>
+                      <a:round/>
+                      <a:headEnd type="none" w="med" len="med"/>
+                      <a:tailEnd type="none" w="med" len="med"/>
+                    </a:lnT>
+                    <a:lnB w="9525" cap="flat" cmpd="sng" algn="ctr">
+                      <a:solidFill>
+                        <a:srgbClr val="BFBFBF"/>
+                      </a:solidFill>
+                      <a:prstDash val="solid"/>
+                      <a:round/>
+                      <a:headEnd type="none" w="med" len="med"/>
+                      <a:tailEnd type="none" w="med" len="med"/>
+                    </a:lnB>
+                    <a:solidFill>
+                      <a:srgbClr val="FFFFFF"/>
                     </a:solidFill>
                   </a:tcPr>
                 </a:tc>
@@ -5141,18 +5079,7 @@
                       <a:pPr algn="ctr" indent="0" marL="0">
                         <a:buNone/>
                       </a:pPr>
-                      <a:r>
-                        <a:rPr lang="en-US" sz="1200" i="1" dirty="0">
-                          <a:solidFill>
-                            <a:srgbClr val="8C8C8C"/>
-                          </a:solidFill>
-                          <a:latin typeface="맑은 고딕" pitchFamily="34" charset="0"/>
-                          <a:ea typeface="맑은 고딕" pitchFamily="34" charset="-122"/>
-                          <a:cs typeface="맑은 고딕" pitchFamily="34" charset="-120"/>
-                        </a:rPr>
-                        <a:t>지원</a:t>
-                      </a:r>
-                      <a:endParaRPr lang="en-US" sz="1200" dirty="0">
+                      <a:endParaRPr lang="en-US" sz="1150" dirty="0">
                         <a:latin typeface="맑은 고딕" charset="0"/>
                         <a:ea typeface="맑은 고딕" charset="0"/>
                         <a:cs typeface="맑은 고딕" charset="0"/>
@@ -5162,42 +5089,42 @@
                   <a:tcPr marL="91440" marR="91440" marT="45720" marB="45720" anchor="ctr">
                     <a:lnL w="9525" cap="flat" cmpd="sng" algn="ctr">
                       <a:solidFill>
-                        <a:srgbClr val="FFFFFF"/>
-                      </a:solidFill>
-                      <a:prstDash val="solid"/>
-                      <a:round/>
-                      <a:headEnd type="none" w="med" len="med"/>
-                      <a:tailEnd type="none" w="med" len="med"/>
-                    </a:lnL>
-                    <a:lnR w="9525" cap="flat" cmpd="sng" algn="ctr">
-                      <a:solidFill>
-                        <a:srgbClr val="FFFFFF"/>
-                      </a:solidFill>
-                      <a:prstDash val="solid"/>
-                      <a:round/>
-                      <a:headEnd type="none" w="med" len="med"/>
-                      <a:tailEnd type="none" w="med" len="med"/>
-                    </a:lnR>
-                    <a:lnT w="9525" cap="flat" cmpd="sng" algn="ctr">
-                      <a:solidFill>
-                        <a:srgbClr val="FFFFFF"/>
-                      </a:solidFill>
-                      <a:prstDash val="solid"/>
-                      <a:round/>
-                      <a:headEnd type="none" w="med" len="med"/>
-                      <a:tailEnd type="none" w="med" len="med"/>
-                    </a:lnT>
-                    <a:lnB w="9525" cap="flat" cmpd="sng" algn="ctr">
-                      <a:solidFill>
-                        <a:srgbClr val="FFFFFF"/>
-                      </a:solidFill>
-                      <a:prstDash val="solid"/>
-                      <a:round/>
-                      <a:headEnd type="none" w="med" len="med"/>
-                      <a:tailEnd type="none" w="med" len="med"/>
-                    </a:lnB>
-                    <a:solidFill>
-                      <a:srgbClr val="DCE5F1"/>
+                        <a:srgbClr val="BFBFBF"/>
+                      </a:solidFill>
+                      <a:prstDash val="solid"/>
+                      <a:round/>
+                      <a:headEnd type="none" w="med" len="med"/>
+                      <a:tailEnd type="none" w="med" len="med"/>
+                    </a:lnL>
+                    <a:lnR w="9525" cap="flat" cmpd="sng" algn="ctr">
+                      <a:solidFill>
+                        <a:srgbClr val="BFBFBF"/>
+                      </a:solidFill>
+                      <a:prstDash val="solid"/>
+                      <a:round/>
+                      <a:headEnd type="none" w="med" len="med"/>
+                      <a:tailEnd type="none" w="med" len="med"/>
+                    </a:lnR>
+                    <a:lnT w="9525" cap="flat" cmpd="sng" algn="ctr">
+                      <a:solidFill>
+                        <a:srgbClr val="BFBFBF"/>
+                      </a:solidFill>
+                      <a:prstDash val="solid"/>
+                      <a:round/>
+                      <a:headEnd type="none" w="med" len="med"/>
+                      <a:tailEnd type="none" w="med" len="med"/>
+                    </a:lnT>
+                    <a:lnB w="9525" cap="flat" cmpd="sng" algn="ctr">
+                      <a:solidFill>
+                        <a:srgbClr val="BFBFBF"/>
+                      </a:solidFill>
+                      <a:prstDash val="solid"/>
+                      <a:round/>
+                      <a:headEnd type="none" w="med" len="med"/>
+                      <a:tailEnd type="none" w="med" len="med"/>
+                    </a:lnB>
+                    <a:solidFill>
+                      <a:srgbClr val="FFFFFF"/>
                     </a:solidFill>
                   </a:tcPr>
                 </a:tc>
@@ -5475,7 +5402,7 @@
                       <a:pPr algn="ctr" indent="0" marL="0">
                         <a:buNone/>
                       </a:pPr>
-                      <a:endParaRPr lang="en-US" sz="1200" dirty="0">
+                      <a:endParaRPr lang="en-US" sz="1150" dirty="0">
                         <a:latin typeface="맑은 고딕" charset="0"/>
                         <a:ea typeface="맑은 고딕" charset="0"/>
                         <a:cs typeface="맑은 고딕" charset="0"/>
@@ -5810,17 +5737,17 @@
                         <a:buNone/>
                       </a:pPr>
                       <a:r>
-                        <a:rPr lang="en-US" sz="1200" i="1" dirty="0">
-                          <a:solidFill>
-                            <a:srgbClr val="FFFFFF"/>
-                          </a:solidFill>
-                          <a:latin typeface="맑은 고딕" pitchFamily="34" charset="0"/>
-                          <a:ea typeface="맑은 고딕" pitchFamily="34" charset="-122"/>
-                          <a:cs typeface="맑은 고딕" pitchFamily="34" charset="-120"/>
-                        </a:rPr>
-                        <a:t>협업</a:t>
-                      </a:r>
-                      <a:endParaRPr lang="en-US" sz="1200" dirty="0">
+                        <a:rPr lang="en-US" sz="1150" b="1" dirty="0">
+                          <a:solidFill>
+                            <a:srgbClr val="1F3F6E"/>
+                          </a:solidFill>
+                          <a:latin typeface="맑은 고딕" pitchFamily="34" charset="0"/>
+                          <a:ea typeface="맑은 고딕" pitchFamily="34" charset="-122"/>
+                          <a:cs typeface="맑은 고딕" pitchFamily="34" charset="-120"/>
+                        </a:rPr>
+                        <a:t>사용자 테스트 수행</a:t>
+                      </a:r>
+                      <a:endParaRPr lang="en-US" sz="1150" dirty="0">
                         <a:latin typeface="맑은 고딕" charset="0"/>
                         <a:ea typeface="맑은 고딕" charset="0"/>
                         <a:cs typeface="맑은 고딕" charset="0"/>
@@ -5830,42 +5757,42 @@
                   <a:tcPr marL="91440" marR="91440" marT="45720" marB="45720" anchor="ctr">
                     <a:lnL w="9525" cap="flat" cmpd="sng" algn="ctr">
                       <a:solidFill>
-                        <a:srgbClr val="FFFFFF"/>
-                      </a:solidFill>
-                      <a:prstDash val="solid"/>
-                      <a:round/>
-                      <a:headEnd type="none" w="med" len="med"/>
-                      <a:tailEnd type="none" w="med" len="med"/>
-                    </a:lnL>
-                    <a:lnR w="9525" cap="flat" cmpd="sng" algn="ctr">
-                      <a:solidFill>
-                        <a:srgbClr val="FFFFFF"/>
-                      </a:solidFill>
-                      <a:prstDash val="solid"/>
-                      <a:round/>
-                      <a:headEnd type="none" w="med" len="med"/>
-                      <a:tailEnd type="none" w="med" len="med"/>
-                    </a:lnR>
-                    <a:lnT w="9525" cap="flat" cmpd="sng" algn="ctr">
-                      <a:solidFill>
-                        <a:srgbClr val="FFFFFF"/>
-                      </a:solidFill>
-                      <a:prstDash val="solid"/>
-                      <a:round/>
-                      <a:headEnd type="none" w="med" len="med"/>
-                      <a:tailEnd type="none" w="med" len="med"/>
-                    </a:lnT>
-                    <a:lnB w="9525" cap="flat" cmpd="sng" algn="ctr">
-                      <a:solidFill>
-                        <a:srgbClr val="FFFFFF"/>
-                      </a:solidFill>
-                      <a:prstDash val="solid"/>
-                      <a:round/>
-                      <a:headEnd type="none" w="med" len="med"/>
-                      <a:tailEnd type="none" w="med" len="med"/>
-                    </a:lnB>
-                    <a:solidFill>
-                      <a:srgbClr val="5B8ED6"/>
+                        <a:srgbClr val="BFBFBF"/>
+                      </a:solidFill>
+                      <a:prstDash val="solid"/>
+                      <a:round/>
+                      <a:headEnd type="none" w="med" len="med"/>
+                      <a:tailEnd type="none" w="med" len="med"/>
+                    </a:lnL>
+                    <a:lnR w="9525" cap="flat" cmpd="sng" algn="ctr">
+                      <a:solidFill>
+                        <a:srgbClr val="BFBFBF"/>
+                      </a:solidFill>
+                      <a:prstDash val="solid"/>
+                      <a:round/>
+                      <a:headEnd type="none" w="med" len="med"/>
+                      <a:tailEnd type="none" w="med" len="med"/>
+                    </a:lnR>
+                    <a:lnT w="9525" cap="flat" cmpd="sng" algn="ctr">
+                      <a:solidFill>
+                        <a:srgbClr val="BFBFBF"/>
+                      </a:solidFill>
+                      <a:prstDash val="solid"/>
+                      <a:round/>
+                      <a:headEnd type="none" w="med" len="med"/>
+                      <a:tailEnd type="none" w="med" len="med"/>
+                    </a:lnT>
+                    <a:lnB w="9525" cap="flat" cmpd="sng" algn="ctr">
+                      <a:solidFill>
+                        <a:srgbClr val="BFBFBF"/>
+                      </a:solidFill>
+                      <a:prstDash val="solid"/>
+                      <a:round/>
+                      <a:headEnd type="none" w="med" len="med"/>
+                      <a:tailEnd type="none" w="med" len="med"/>
+                    </a:lnB>
+                    <a:solidFill>
+                      <a:srgbClr val="EAF0F8"/>
                     </a:solidFill>
                   </a:tcPr>
                 </a:tc>
@@ -6241,17 +6168,17 @@
                         <a:buNone/>
                       </a:pPr>
                       <a:r>
-                        <a:rPr lang="en-US" sz="1200" i="1" dirty="0">
-                          <a:solidFill>
-                            <a:srgbClr val="FFFFFF"/>
-                          </a:solidFill>
-                          <a:latin typeface="맑은 고딕" pitchFamily="34" charset="0"/>
-                          <a:ea typeface="맑은 고딕" pitchFamily="34" charset="-122"/>
-                          <a:cs typeface="맑은 고딕" pitchFamily="34" charset="-120"/>
-                        </a:rPr>
-                        <a:t>협업</a:t>
-                      </a:r>
-                      <a:endParaRPr lang="en-US" sz="1200" dirty="0">
+                        <a:rPr lang="en-US" sz="1150" b="1" dirty="0">
+                          <a:solidFill>
+                            <a:srgbClr val="1F3F6E"/>
+                          </a:solidFill>
+                          <a:latin typeface="맑은 고딕" pitchFamily="34" charset="0"/>
+                          <a:ea typeface="맑은 고딕" pitchFamily="34" charset="-122"/>
+                          <a:cs typeface="맑은 고딕" pitchFamily="34" charset="-120"/>
+                        </a:rPr>
+                        <a:t>KPI 목표 합의</a:t>
+                      </a:r>
+                      <a:endParaRPr lang="en-US" sz="1150" dirty="0">
                         <a:latin typeface="맑은 고딕" charset="0"/>
                         <a:ea typeface="맑은 고딕" charset="0"/>
                         <a:cs typeface="맑은 고딕" charset="0"/>
@@ -6261,42 +6188,42 @@
                   <a:tcPr marL="91440" marR="91440" marT="45720" marB="45720" anchor="ctr">
                     <a:lnL w="9525" cap="flat" cmpd="sng" algn="ctr">
                       <a:solidFill>
-                        <a:srgbClr val="FFFFFF"/>
-                      </a:solidFill>
-                      <a:prstDash val="solid"/>
-                      <a:round/>
-                      <a:headEnd type="none" w="med" len="med"/>
-                      <a:tailEnd type="none" w="med" len="med"/>
-                    </a:lnL>
-                    <a:lnR w="9525" cap="flat" cmpd="sng" algn="ctr">
-                      <a:solidFill>
-                        <a:srgbClr val="FFFFFF"/>
-                      </a:solidFill>
-                      <a:prstDash val="solid"/>
-                      <a:round/>
-                      <a:headEnd type="none" w="med" len="med"/>
-                      <a:tailEnd type="none" w="med" len="med"/>
-                    </a:lnR>
-                    <a:lnT w="9525" cap="flat" cmpd="sng" algn="ctr">
-                      <a:solidFill>
-                        <a:srgbClr val="FFFFFF"/>
-                      </a:solidFill>
-                      <a:prstDash val="solid"/>
-                      <a:round/>
-                      <a:headEnd type="none" w="med" len="med"/>
-                      <a:tailEnd type="none" w="med" len="med"/>
-                    </a:lnT>
-                    <a:lnB w="9525" cap="flat" cmpd="sng" algn="ctr">
-                      <a:solidFill>
-                        <a:srgbClr val="FFFFFF"/>
-                      </a:solidFill>
-                      <a:prstDash val="solid"/>
-                      <a:round/>
-                      <a:headEnd type="none" w="med" len="med"/>
-                      <a:tailEnd type="none" w="med" len="med"/>
-                    </a:lnB>
-                    <a:solidFill>
-                      <a:srgbClr val="5B8ED6"/>
+                        <a:srgbClr val="BFBFBF"/>
+                      </a:solidFill>
+                      <a:prstDash val="solid"/>
+                      <a:round/>
+                      <a:headEnd type="none" w="med" len="med"/>
+                      <a:tailEnd type="none" w="med" len="med"/>
+                    </a:lnL>
+                    <a:lnR w="9525" cap="flat" cmpd="sng" algn="ctr">
+                      <a:solidFill>
+                        <a:srgbClr val="BFBFBF"/>
+                      </a:solidFill>
+                      <a:prstDash val="solid"/>
+                      <a:round/>
+                      <a:headEnd type="none" w="med" len="med"/>
+                      <a:tailEnd type="none" w="med" len="med"/>
+                    </a:lnR>
+                    <a:lnT w="9525" cap="flat" cmpd="sng" algn="ctr">
+                      <a:solidFill>
+                        <a:srgbClr val="BFBFBF"/>
+                      </a:solidFill>
+                      <a:prstDash val="solid"/>
+                      <a:round/>
+                      <a:headEnd type="none" w="med" len="med"/>
+                      <a:tailEnd type="none" w="med" len="med"/>
+                    </a:lnT>
+                    <a:lnB w="9525" cap="flat" cmpd="sng" algn="ctr">
+                      <a:solidFill>
+                        <a:srgbClr val="BFBFBF"/>
+                      </a:solidFill>
+                      <a:prstDash val="solid"/>
+                      <a:round/>
+                      <a:headEnd type="none" w="med" len="med"/>
+                      <a:tailEnd type="none" w="med" len="med"/>
+                    </a:lnB>
+                    <a:solidFill>
+                      <a:srgbClr val="EAF0F8"/>
                     </a:solidFill>
                   </a:tcPr>
                 </a:tc>
@@ -6599,18 +6526,7 @@
                       <a:pPr algn="ctr" indent="0" marL="0">
                         <a:buNone/>
                       </a:pPr>
-                      <a:r>
-                        <a:rPr lang="en-US" sz="1200" i="1" dirty="0">
-                          <a:solidFill>
-                            <a:srgbClr val="FFFFFF"/>
-                          </a:solidFill>
-                          <a:latin typeface="맑은 고딕" pitchFamily="34" charset="0"/>
-                          <a:ea typeface="맑은 고딕" pitchFamily="34" charset="-122"/>
-                          <a:cs typeface="맑은 고딕" pitchFamily="34" charset="-120"/>
-                        </a:rPr>
-                        <a:t>협업</a:t>
-                      </a:r>
-                      <a:endParaRPr lang="en-US" sz="1200" dirty="0">
+                      <a:endParaRPr lang="en-US" sz="1150" dirty="0">
                         <a:latin typeface="맑은 고딕" charset="0"/>
                         <a:ea typeface="맑은 고딕" charset="0"/>
                         <a:cs typeface="맑은 고딕" charset="0"/>
@@ -6620,42 +6536,42 @@
                   <a:tcPr marL="91440" marR="91440" marT="45720" marB="45720" anchor="ctr">
                     <a:lnL w="9525" cap="flat" cmpd="sng" algn="ctr">
                       <a:solidFill>
-                        <a:srgbClr val="FFFFFF"/>
-                      </a:solidFill>
-                      <a:prstDash val="solid"/>
-                      <a:round/>
-                      <a:headEnd type="none" w="med" len="med"/>
-                      <a:tailEnd type="none" w="med" len="med"/>
-                    </a:lnL>
-                    <a:lnR w="9525" cap="flat" cmpd="sng" algn="ctr">
-                      <a:solidFill>
-                        <a:srgbClr val="FFFFFF"/>
-                      </a:solidFill>
-                      <a:prstDash val="solid"/>
-                      <a:round/>
-                      <a:headEnd type="none" w="med" len="med"/>
-                      <a:tailEnd type="none" w="med" len="med"/>
-                    </a:lnR>
-                    <a:lnT w="9525" cap="flat" cmpd="sng" algn="ctr">
-                      <a:solidFill>
-                        <a:srgbClr val="FFFFFF"/>
-                      </a:solidFill>
-                      <a:prstDash val="solid"/>
-                      <a:round/>
-                      <a:headEnd type="none" w="med" len="med"/>
-                      <a:tailEnd type="none" w="med" len="med"/>
-                    </a:lnT>
-                    <a:lnB w="9525" cap="flat" cmpd="sng" algn="ctr">
-                      <a:solidFill>
-                        <a:srgbClr val="FFFFFF"/>
-                      </a:solidFill>
-                      <a:prstDash val="solid"/>
-                      <a:round/>
-                      <a:headEnd type="none" w="med" len="med"/>
-                      <a:tailEnd type="none" w="med" len="med"/>
-                    </a:lnB>
-                    <a:solidFill>
-                      <a:srgbClr val="5B8ED6"/>
+                        <a:srgbClr val="BFBFBF"/>
+                      </a:solidFill>
+                      <a:prstDash val="solid"/>
+                      <a:round/>
+                      <a:headEnd type="none" w="med" len="med"/>
+                      <a:tailEnd type="none" w="med" len="med"/>
+                    </a:lnL>
+                    <a:lnR w="9525" cap="flat" cmpd="sng" algn="ctr">
+                      <a:solidFill>
+                        <a:srgbClr val="BFBFBF"/>
+                      </a:solidFill>
+                      <a:prstDash val="solid"/>
+                      <a:round/>
+                      <a:headEnd type="none" w="med" len="med"/>
+                      <a:tailEnd type="none" w="med" len="med"/>
+                    </a:lnR>
+                    <a:lnT w="9525" cap="flat" cmpd="sng" algn="ctr">
+                      <a:solidFill>
+                        <a:srgbClr val="BFBFBF"/>
+                      </a:solidFill>
+                      <a:prstDash val="solid"/>
+                      <a:round/>
+                      <a:headEnd type="none" w="med" len="med"/>
+                      <a:tailEnd type="none" w="med" len="med"/>
+                    </a:lnT>
+                    <a:lnB w="9525" cap="flat" cmpd="sng" algn="ctr">
+                      <a:solidFill>
+                        <a:srgbClr val="BFBFBF"/>
+                      </a:solidFill>
+                      <a:prstDash val="solid"/>
+                      <a:round/>
+                      <a:headEnd type="none" w="med" len="med"/>
+                      <a:tailEnd type="none" w="med" len="med"/>
+                    </a:lnB>
+                    <a:solidFill>
+                      <a:srgbClr val="FFFFFF"/>
                     </a:solidFill>
                   </a:tcPr>
                 </a:tc>
@@ -6945,17 +6861,17 @@
                         <a:buNone/>
                       </a:pPr>
                       <a:r>
-                        <a:rPr lang="en-US" sz="1200" i="1" dirty="0">
-                          <a:solidFill>
-                            <a:srgbClr val="FFFFFF"/>
-                          </a:solidFill>
-                          <a:latin typeface="맑은 고딕" pitchFamily="34" charset="0"/>
-                          <a:ea typeface="맑은 고딕" pitchFamily="34" charset="-122"/>
-                          <a:cs typeface="맑은 고딕" pitchFamily="34" charset="-120"/>
-                        </a:rPr>
-                        <a:t>협업</a:t>
-                      </a:r>
-                      <a:endParaRPr lang="en-US" sz="1200" dirty="0">
+                        <a:rPr lang="en-US" sz="1150" b="1" dirty="0">
+                          <a:solidFill>
+                            <a:srgbClr val="1F3F6E"/>
+                          </a:solidFill>
+                          <a:latin typeface="맑은 고딕" pitchFamily="34" charset="0"/>
+                          <a:ea typeface="맑은 고딕" pitchFamily="34" charset="-122"/>
+                          <a:cs typeface="맑은 고딕" pitchFamily="34" charset="-120"/>
+                        </a:rPr>
+                        <a:t>운영 인수·정착</a:t>
+                      </a:r>
+                      <a:endParaRPr lang="en-US" sz="1150" dirty="0">
                         <a:latin typeface="맑은 고딕" charset="0"/>
                         <a:ea typeface="맑은 고딕" charset="0"/>
                         <a:cs typeface="맑은 고딕" charset="0"/>
@@ -6965,42 +6881,42 @@
                   <a:tcPr marL="91440" marR="91440" marT="45720" marB="45720" anchor="ctr">
                     <a:lnL w="9525" cap="flat" cmpd="sng" algn="ctr">
                       <a:solidFill>
-                        <a:srgbClr val="FFFFFF"/>
-                      </a:solidFill>
-                      <a:prstDash val="solid"/>
-                      <a:round/>
-                      <a:headEnd type="none" w="med" len="med"/>
-                      <a:tailEnd type="none" w="med" len="med"/>
-                    </a:lnL>
-                    <a:lnR w="9525" cap="flat" cmpd="sng" algn="ctr">
-                      <a:solidFill>
-                        <a:srgbClr val="FFFFFF"/>
-                      </a:solidFill>
-                      <a:prstDash val="solid"/>
-                      <a:round/>
-                      <a:headEnd type="none" w="med" len="med"/>
-                      <a:tailEnd type="none" w="med" len="med"/>
-                    </a:lnR>
-                    <a:lnT w="9525" cap="flat" cmpd="sng" algn="ctr">
-                      <a:solidFill>
-                        <a:srgbClr val="FFFFFF"/>
-                      </a:solidFill>
-                      <a:prstDash val="solid"/>
-                      <a:round/>
-                      <a:headEnd type="none" w="med" len="med"/>
-                      <a:tailEnd type="none" w="med" len="med"/>
-                    </a:lnT>
-                    <a:lnB w="9525" cap="flat" cmpd="sng" algn="ctr">
-                      <a:solidFill>
-                        <a:srgbClr val="FFFFFF"/>
-                      </a:solidFill>
-                      <a:prstDash val="solid"/>
-                      <a:round/>
-                      <a:headEnd type="none" w="med" len="med"/>
-                      <a:tailEnd type="none" w="med" len="med"/>
-                    </a:lnB>
-                    <a:solidFill>
-                      <a:srgbClr val="5B8ED6"/>
+                        <a:srgbClr val="BFBFBF"/>
+                      </a:solidFill>
+                      <a:prstDash val="solid"/>
+                      <a:round/>
+                      <a:headEnd type="none" w="med" len="med"/>
+                      <a:tailEnd type="none" w="med" len="med"/>
+                    </a:lnL>
+                    <a:lnR w="9525" cap="flat" cmpd="sng" algn="ctr">
+                      <a:solidFill>
+                        <a:srgbClr val="BFBFBF"/>
+                      </a:solidFill>
+                      <a:prstDash val="solid"/>
+                      <a:round/>
+                      <a:headEnd type="none" w="med" len="med"/>
+                      <a:tailEnd type="none" w="med" len="med"/>
+                    </a:lnR>
+                    <a:lnT w="9525" cap="flat" cmpd="sng" algn="ctr">
+                      <a:solidFill>
+                        <a:srgbClr val="BFBFBF"/>
+                      </a:solidFill>
+                      <a:prstDash val="solid"/>
+                      <a:round/>
+                      <a:headEnd type="none" w="med" len="med"/>
+                      <a:tailEnd type="none" w="med" len="med"/>
+                    </a:lnT>
+                    <a:lnB w="9525" cap="flat" cmpd="sng" algn="ctr">
+                      <a:solidFill>
+                        <a:srgbClr val="BFBFBF"/>
+                      </a:solidFill>
+                      <a:prstDash val="solid"/>
+                      <a:round/>
+                      <a:headEnd type="none" w="med" len="med"/>
+                      <a:tailEnd type="none" w="med" len="med"/>
+                    </a:lnB>
+                    <a:solidFill>
+                      <a:srgbClr val="EAF0F8"/>
                     </a:solidFill>
                   </a:tcPr>
                 </a:tc>

</xml_diff>